<commit_message>
feat: update presentation deck with latest edits and add official unlisted demo video link
</commit_message>
<xml_diff>
--- a/docs/AarogyaTwin-X.pptx
+++ b/docs/AarogyaTwin-X.pptx
@@ -237,7 +237,7 @@
           <a:p>
             <a:fld id="{8B7A97D9-1E28-4E96-A35E-EFCDB2F22B78}" type="datetimeFigureOut">
               <a:rPr lang="en-IN"/>
-              <a:t>17-10-2026</a:t>
+              <a:t>19-10-2026</a:t>
             </a:fld>
             <a:endParaRPr lang="en-IN"/>
           </a:p>
@@ -1635,7 +1635,7 @@
           <a:p>
             <a:fld id="{5BCAD085-E8A6-8845-BD4E-CB4CCA059FC4}" type="datetimeFigureOut">
               <a:rPr lang="en-US"/>
-              <a:t>10/17/2026</a:t>
+              <a:t>10/19/2026</a:t>
             </a:fld>
             <a:endParaRPr lang="en-US"/>
           </a:p>
@@ -2509,7 +2509,7 @@
           <a:p>
             <a:fld id="{5BCAD085-E8A6-8845-BD4E-CB4CCA059FC4}" type="datetimeFigureOut">
               <a:rPr lang="en-US"/>
-              <a:t>10/17/2026</a:t>
+              <a:t>10/19/2026</a:t>
             </a:fld>
             <a:endParaRPr lang="en-US"/>
           </a:p>
@@ -4254,7 +4254,7 @@
         </p:nvSpPr>
         <p:spPr>
           <a:xfrm>
-            <a:off x="723900" y="5905500"/>
+            <a:off x="723900" y="5748338"/>
             <a:ext cx="371177" cy="381000"/>
           </a:xfrm>
           <a:prstGeom prst="roundRect">
@@ -4827,7 +4827,7 @@
           <a:p>
             <a:pPr algn="l"/>
             <a:r>
-              <a:rPr sz="4500" b="1" i="0" u="none">
+              <a:rPr sz="4500" b="1" i="0" u="none" dirty="0" err="1">
                 <a:solidFill>
                   <a:srgbClr val="F8FAFC"/>
                 </a:solidFill>
@@ -4836,7 +4836,7 @@
               <a:t>AarogyaTwin</a:t>
             </a:r>
             <a:r>
-              <a:rPr sz="4500" b="1" i="0" u="none">
+              <a:rPr sz="4500" b="1" i="0" u="none" dirty="0">
                 <a:solidFill>
                   <a:srgbClr val="22D3EE"/>
                 </a:solidFill>
@@ -5617,7 +5617,7 @@
         </p:nvSpPr>
         <p:spPr>
           <a:xfrm>
-            <a:off x="795188" y="6010275"/>
+            <a:off x="795188" y="5819775"/>
             <a:ext cx="514350" cy="171450"/>
           </a:xfrm>
           <a:prstGeom prst="rect">
@@ -5652,7 +5652,7 @@
         </p:nvSpPr>
         <p:spPr>
           <a:xfrm>
-            <a:off x="1140246" y="5962650"/>
+            <a:off x="1169901" y="5815012"/>
             <a:ext cx="762446" cy="342900"/>
           </a:xfrm>
           <a:prstGeom prst="rect">
@@ -5687,7 +5687,7 @@
         </p:nvSpPr>
         <p:spPr>
           <a:xfrm>
-            <a:off x="1169901" y="6099073"/>
+            <a:off x="1178038" y="5921589"/>
             <a:ext cx="546112" cy="207749"/>
           </a:xfrm>
           <a:prstGeom prst="rect">
@@ -11657,11 +11657,10 @@
           </a:bodyPr>
           <a:lstStyle/>
           <a:p>
-            <a:pPr marL="0" indent="0" algn="l">
+            <a:pPr>
               <a:lnSpc>
                 <a:spcPts val="1960"/>
               </a:lnSpc>
-              <a:buNone/>
             </a:pPr>
             <a:r>
               <a:rPr lang="en-US" sz="1400" dirty="0">
@@ -11672,7 +11671,7 @@
                 <a:ea typeface="JetBrains Mono" pitchFamily="49" charset="-122"/>
                 <a:cs typeface="JetBrains Mono" pitchFamily="49" charset="-120"/>
               </a:rPr>
-              <a:t>github.com/[YOUR_USERNAME]/aarogya-twin-x</a:t>
+              <a:t>https://github.com/Amit-kumar-Yadav14/AarogyaTwin-X</a:t>
             </a:r>
             <a:endParaRPr lang="en-US" sz="1400" dirty="0"/>
           </a:p>
@@ -11788,11 +11787,10 @@
           </a:bodyPr>
           <a:lstStyle/>
           <a:p>
-            <a:pPr marL="0" indent="0" algn="l">
+            <a:pPr>
               <a:lnSpc>
                 <a:spcPts val="1960"/>
               </a:lnSpc>
-              <a:buNone/>
             </a:pPr>
             <a:r>
               <a:rPr lang="en-US" sz="1400" dirty="0">
@@ -11803,7 +11801,7 @@
                 <a:ea typeface="JetBrains Mono" pitchFamily="49" charset="-122"/>
                 <a:cs typeface="JetBrains Mono" pitchFamily="49" charset="-120"/>
               </a:rPr>
-              <a:t>youtube.com/[YOUR_VIDEO_LINK]</a:t>
+              <a:t>https://youtu.be/3ck4XbOvc_Y</a:t>
             </a:r>
             <a:endParaRPr lang="en-US" sz="1400" dirty="0"/>
           </a:p>

</xml_diff>